<commit_message>
Add team member names to title slide, final clean UNT presentation
</commit_message>
<xml_diff>
--- a/slides/Group18_UNT_Presentation.pptx
+++ b/slides/Group18_UNT_Presentation.pptx
@@ -21,9 +21,9 @@
     <p:sldId id="303" r:id="rId12"/>
     <p:sldId id="304" r:id="rId13"/>
     <p:sldId id="316" r:id="rId14"/>
-    <p:sldId id="318" r:id="rId26"/>
-    <p:sldId id="319" r:id="rId27"/>
-    <p:sldId id="320" r:id="rId28"/>
+    <p:sldId id="282" r:id="rId15"/>
+    <p:sldId id="305" r:id="rId16"/>
+    <p:sldId id="300" r:id="rId17"/>
   </p:sldIdLst>
   <p:sldSz cx="12192000" cy="6858000"/>
   <p:notesSz cx="6858000" cy="9144000"/>
@@ -1615,7 +1615,7 @@
               </a:spcBef>
             </a:pPr>
             <a:r>
-              <a:rPr sz="3400" b="0">
+              <a:rPr sz="3200" b="0">
                 <a:solidFill>
                   <a:srgbClr val="000000"/>
                 </a:solidFill>
@@ -1631,9 +1631,9 @@
               </a:spcBef>
             </a:pPr>
             <a:r>
-              <a:rPr sz="2600" b="0">
-                <a:solidFill>
-                  <a:srgbClr val="333333"/>
+              <a:rPr sz="2400" b="0">
+                <a:solidFill>
+                  <a:srgbClr val="444444"/>
                 </a:solidFill>
               </a:rPr>
               <a:t>Hybrid, Automated, and Interpretable Approaches</a:t>
@@ -1667,6 +1667,108 @@
               <a:t>1</a:t>
             </a:fld>
             <a:endParaRPr lang="en-US"/>
+          </a:p>
+        </p:txBody>
+      </p:sp>
+      <p:sp>
+        <p:nvSpPr>
+          <p:cNvPr id="5" name="TextBox 4"/>
+          <p:cNvSpPr txBox="1"/>
+          <p:nvPr/>
+        </p:nvSpPr>
+        <p:spPr>
+          <a:xfrm>
+            <a:off x="1371600" y="3566160"/>
+            <a:ext cx="9445752" cy="457200"/>
+          </a:xfrm>
+          <a:prstGeom prst="rect">
+            <a:avLst/>
+          </a:prstGeom>
+          <a:noFill/>
+        </p:spPr>
+        <p:txBody>
+          <a:bodyPr wrap="square">
+            <a:spAutoFit/>
+          </a:bodyPr>
+          <a:lstStyle/>
+          <a:p>
+            <a:pPr algn="ctr"/>
+            <a:r>
+              <a:rPr sz="1800" b="0">
+                <a:solidFill>
+                  <a:srgbClr val="00853E"/>
+                </a:solidFill>
+              </a:rPr>
+              <a:t>CSCE 5222 Feature Engineering  |  Group 18</a:t>
+            </a:r>
+          </a:p>
+        </p:txBody>
+      </p:sp>
+      <p:sp>
+        <p:nvSpPr>
+          <p:cNvPr id="6" name="TextBox 5"/>
+          <p:cNvSpPr txBox="1"/>
+          <p:nvPr/>
+        </p:nvSpPr>
+        <p:spPr>
+          <a:xfrm>
+            <a:off x="1371600" y="4114800"/>
+            <a:ext cx="9445752" cy="502920"/>
+          </a:xfrm>
+          <a:prstGeom prst="rect">
+            <a:avLst/>
+          </a:prstGeom>
+          <a:noFill/>
+        </p:spPr>
+        <p:txBody>
+          <a:bodyPr wrap="square">
+            <a:spAutoFit/>
+          </a:bodyPr>
+          <a:lstStyle/>
+          <a:p>
+            <a:pPr algn="ctr"/>
+            <a:r>
+              <a:rPr sz="2000" b="1">
+                <a:solidFill>
+                  <a:srgbClr val="000000"/>
+                </a:solidFill>
+              </a:rPr>
+              <a:t>Ashish Rathnakar Shetty (ID: 11808466)  ·  Kushal Sai Venigalla (ID: 11852559)</a:t>
+            </a:r>
+          </a:p>
+        </p:txBody>
+      </p:sp>
+      <p:sp>
+        <p:nvSpPr>
+          <p:cNvPr id="7" name="TextBox 6"/>
+          <p:cNvSpPr txBox="1"/>
+          <p:nvPr/>
+        </p:nvSpPr>
+        <p:spPr>
+          <a:xfrm>
+            <a:off x="1371600" y="4709160"/>
+            <a:ext cx="9445752" cy="411480"/>
+          </a:xfrm>
+          <a:prstGeom prst="rect">
+            <a:avLst/>
+          </a:prstGeom>
+          <a:noFill/>
+        </p:spPr>
+        <p:txBody>
+          <a:bodyPr wrap="square">
+            <a:spAutoFit/>
+          </a:bodyPr>
+          <a:lstStyle/>
+          <a:p>
+            <a:pPr algn="ctr"/>
+            <a:r>
+              <a:rPr sz="1600" b="0">
+                <a:solidFill>
+                  <a:srgbClr val="444444"/>
+                </a:solidFill>
+              </a:rPr>
+              <a:t>Computer Science and Engineering Department  |  University of North Texas</a:t>
+            </a:r>
           </a:p>
         </p:txBody>
       </p:sp>
@@ -1916,6 +2018,7 @@
           </a:bodyPr>
           <a:lstStyle/>
           <a:p>
+            <a:pPr algn="l"/>
             <a:r>
               <a:rPr sz="1700" b="1">
                 <a:solidFill>
@@ -1949,6 +2052,7 @@
           </a:bodyPr>
           <a:lstStyle/>
           <a:p>
+            <a:pPr algn="l"/>
             <a:r>
               <a:rPr sz="1500" b="0">
                 <a:solidFill>
@@ -1968,7 +2072,7 @@
         </p:nvSpPr>
         <p:spPr>
           <a:xfrm>
-            <a:off x="7680960" y="2542032"/>
+            <a:off x="7680960" y="2560320"/>
             <a:ext cx="4297680" cy="411480"/>
           </a:xfrm>
           <a:prstGeom prst="rect">
@@ -1982,6 +2086,7 @@
           </a:bodyPr>
           <a:lstStyle/>
           <a:p>
+            <a:pPr algn="l"/>
             <a:r>
               <a:rPr sz="1500" b="1">
                 <a:solidFill>
@@ -2001,7 +2106,7 @@
         </p:nvSpPr>
         <p:spPr>
           <a:xfrm>
-            <a:off x="7680960" y="2980944"/>
+            <a:off x="7680960" y="3017520"/>
             <a:ext cx="4297680" cy="411480"/>
           </a:xfrm>
           <a:prstGeom prst="rect">
@@ -2015,6 +2120,7 @@
           </a:bodyPr>
           <a:lstStyle/>
           <a:p>
+            <a:pPr algn="l"/>
             <a:r>
               <a:rPr sz="1500" b="0">
                 <a:solidFill>
@@ -2034,7 +2140,7 @@
         </p:nvSpPr>
         <p:spPr>
           <a:xfrm>
-            <a:off x="7680960" y="3419856"/>
+            <a:off x="7680960" y="3474720"/>
             <a:ext cx="4297680" cy="411480"/>
           </a:xfrm>
           <a:prstGeom prst="rect">
@@ -2048,6 +2154,7 @@
           </a:bodyPr>
           <a:lstStyle/>
           <a:p>
+            <a:pPr algn="l"/>
             <a:r>
               <a:rPr sz="1500" b="1">
                 <a:solidFill>
@@ -2067,7 +2174,7 @@
         </p:nvSpPr>
         <p:spPr>
           <a:xfrm>
-            <a:off x="7680960" y="3858768"/>
+            <a:off x="7680960" y="3931920"/>
             <a:ext cx="4297680" cy="411480"/>
           </a:xfrm>
           <a:prstGeom prst="rect">
@@ -2081,6 +2188,7 @@
           </a:bodyPr>
           <a:lstStyle/>
           <a:p>
+            <a:pPr algn="l"/>
             <a:r>
               <a:rPr sz="1500" b="0">
                 <a:solidFill>
@@ -2100,7 +2208,7 @@
         </p:nvSpPr>
         <p:spPr>
           <a:xfrm>
-            <a:off x="7680960" y="4297679"/>
+            <a:off x="7680960" y="4389120"/>
             <a:ext cx="4297680" cy="411480"/>
           </a:xfrm>
           <a:prstGeom prst="rect">
@@ -2114,6 +2222,7 @@
           </a:bodyPr>
           <a:lstStyle/>
           <a:p>
+            <a:pPr algn="l"/>
             <a:r>
               <a:rPr sz="1500" b="0">
                 <a:solidFill>
@@ -2133,7 +2242,7 @@
         </p:nvSpPr>
         <p:spPr>
           <a:xfrm>
-            <a:off x="7680960" y="4736592"/>
+            <a:off x="7680960" y="4846320"/>
             <a:ext cx="4297680" cy="411480"/>
           </a:xfrm>
           <a:prstGeom prst="rect">
@@ -2147,6 +2256,7 @@
           </a:bodyPr>
           <a:lstStyle/>
           <a:p>
+            <a:pPr algn="l"/>
             <a:r>
               <a:rPr sz="1500" b="0">
                 <a:solidFill>
@@ -2166,7 +2276,7 @@
         </p:nvSpPr>
         <p:spPr>
           <a:xfrm>
-            <a:off x="7680960" y="5175504"/>
+            <a:off x="7680960" y="5303520"/>
             <a:ext cx="4297680" cy="411480"/>
           </a:xfrm>
           <a:prstGeom prst="rect">
@@ -2180,6 +2290,7 @@
           </a:bodyPr>
           <a:lstStyle/>
           <a:p>
+            <a:pPr algn="l"/>
             <a:r>
               <a:rPr sz="1500" b="0">
                 <a:solidFill>
@@ -2199,7 +2310,7 @@
         </p:nvSpPr>
         <p:spPr>
           <a:xfrm>
-            <a:off x="7680960" y="5614416"/>
+            <a:off x="7680960" y="5760720"/>
             <a:ext cx="4297680" cy="411480"/>
           </a:xfrm>
           <a:prstGeom prst="rect">
@@ -2213,6 +2324,7 @@
           </a:bodyPr>
           <a:lstStyle/>
           <a:p>
+            <a:pPr algn="l"/>
             <a:r>
               <a:rPr sz="1500" b="0">
                 <a:solidFill>
@@ -2470,6 +2582,7 @@
           </a:bodyPr>
           <a:lstStyle/>
           <a:p>
+            <a:pPr algn="l"/>
             <a:r>
               <a:rPr sz="1700" b="1">
                 <a:solidFill>
@@ -2503,6 +2616,7 @@
           </a:bodyPr>
           <a:lstStyle/>
           <a:p>
+            <a:pPr algn="l"/>
             <a:r>
               <a:rPr sz="1500" b="0">
                 <a:solidFill>
@@ -2522,7 +2636,7 @@
         </p:nvSpPr>
         <p:spPr>
           <a:xfrm>
-            <a:off x="8321040" y="2542032"/>
+            <a:off x="8321040" y="2560320"/>
             <a:ext cx="3657600" cy="411480"/>
           </a:xfrm>
           <a:prstGeom prst="rect">
@@ -2536,10 +2650,11 @@
           </a:bodyPr>
           <a:lstStyle/>
           <a:p>
+            <a:pPr algn="l"/>
             <a:r>
               <a:rPr sz="1500" b="0">
                 <a:solidFill>
-                  <a:srgbClr val="333333"/>
+                  <a:srgbClr val="444444"/>
                 </a:solidFill>
               </a:rPr>
               <a:t>Catch22 Only:  F1 = 0.581 ↓</a:t>
@@ -2555,7 +2670,7 @@
         </p:nvSpPr>
         <p:spPr>
           <a:xfrm>
-            <a:off x="8321040" y="2980944"/>
+            <a:off x="8321040" y="3017520"/>
             <a:ext cx="3657600" cy="411480"/>
           </a:xfrm>
           <a:prstGeom prst="rect">
@@ -2569,6 +2684,7 @@
           </a:bodyPr>
           <a:lstStyle/>
           <a:p>
+            <a:pPr algn="l"/>
             <a:r>
               <a:rPr sz="1500" b="1">
                 <a:solidFill>
@@ -2588,7 +2704,7 @@
         </p:nvSpPr>
         <p:spPr>
           <a:xfrm>
-            <a:off x="8321040" y="3419856"/>
+            <a:off x="8321040" y="3474720"/>
             <a:ext cx="3657600" cy="411480"/>
           </a:xfrm>
           <a:prstGeom prst="rect">
@@ -2602,6 +2718,7 @@
           </a:bodyPr>
           <a:lstStyle/>
           <a:p>
+            <a:pPr algn="l"/>
             <a:r>
               <a:rPr sz="1500" b="0">
                 <a:solidFill>
@@ -2621,7 +2738,7 @@
         </p:nvSpPr>
         <p:spPr>
           <a:xfrm>
-            <a:off x="8321040" y="3858768"/>
+            <a:off x="8321040" y="3931920"/>
             <a:ext cx="3657600" cy="411480"/>
           </a:xfrm>
           <a:prstGeom prst="rect">
@@ -2635,6 +2752,7 @@
           </a:bodyPr>
           <a:lstStyle/>
           <a:p>
+            <a:pPr algn="l"/>
             <a:r>
               <a:rPr sz="1500" b="1">
                 <a:solidFill>
@@ -2654,7 +2772,7 @@
         </p:nvSpPr>
         <p:spPr>
           <a:xfrm>
-            <a:off x="8321040" y="4297679"/>
+            <a:off x="8321040" y="4389120"/>
             <a:ext cx="3657600" cy="411480"/>
           </a:xfrm>
           <a:prstGeom prst="rect">
@@ -2668,6 +2786,7 @@
           </a:bodyPr>
           <a:lstStyle/>
           <a:p>
+            <a:pPr algn="l"/>
             <a:r>
               <a:rPr sz="1500" b="0">
                 <a:solidFill>
@@ -2687,7 +2806,7 @@
         </p:nvSpPr>
         <p:spPr>
           <a:xfrm>
-            <a:off x="8321040" y="4736592"/>
+            <a:off x="8321040" y="4846320"/>
             <a:ext cx="3657600" cy="411480"/>
           </a:xfrm>
           <a:prstGeom prst="rect">
@@ -2701,6 +2820,7 @@
           </a:bodyPr>
           <a:lstStyle/>
           <a:p>
+            <a:pPr algn="l"/>
             <a:r>
               <a:rPr sz="1500" b="0">
                 <a:solidFill>
@@ -2720,7 +2840,7 @@
         </p:nvSpPr>
         <p:spPr>
           <a:xfrm>
-            <a:off x="8321040" y="5175504"/>
+            <a:off x="8321040" y="5303520"/>
             <a:ext cx="3657600" cy="411480"/>
           </a:xfrm>
           <a:prstGeom prst="rect">
@@ -2734,6 +2854,7 @@
           </a:bodyPr>
           <a:lstStyle/>
           <a:p>
+            <a:pPr algn="l"/>
             <a:r>
               <a:rPr sz="1500" b="0">
                 <a:solidFill>
@@ -2753,7 +2874,7 @@
         </p:nvSpPr>
         <p:spPr>
           <a:xfrm>
-            <a:off x="8321040" y="5614416"/>
+            <a:off x="8321040" y="5760720"/>
             <a:ext cx="3657600" cy="411480"/>
           </a:xfrm>
           <a:prstGeom prst="rect">
@@ -2767,6 +2888,7 @@
           </a:bodyPr>
           <a:lstStyle/>
           <a:p>
+            <a:pPr algn="l"/>
             <a:r>
               <a:rPr sz="1500" b="0">
                 <a:solidFill>
@@ -2786,7 +2908,7 @@
         </p:nvSpPr>
         <p:spPr>
           <a:xfrm>
-            <a:off x="8321040" y="6053328"/>
+            <a:off x="8321040" y="6217920"/>
             <a:ext cx="3657600" cy="411480"/>
           </a:xfrm>
           <a:prstGeom prst="rect">
@@ -2800,6 +2922,7 @@
           </a:bodyPr>
           <a:lstStyle/>
           <a:p>
+            <a:pPr algn="l"/>
             <a:r>
               <a:rPr sz="1500" b="0">
                 <a:solidFill>
@@ -3314,7 +3437,7 @@
             <a:r>
               <a:rPr sz="1800" b="0">
                 <a:solidFill>
-                  <a:srgbClr val="333333"/>
+                  <a:srgbClr val="444444"/>
                 </a:solidFill>
               </a:rPr>
               <a:t>Challenges: WESAD-like data is simulated; real wearable data may differ significantly</a:t>
@@ -3442,12 +3565,21 @@
         </p:nvSpPr>
         <p:spPr/>
         <p:txBody>
-          <a:bodyPr/>
-          <a:lstStyle/>
-          <a:p>
-            <a:r>
-              <a:rPr lang="en-US" dirty="0"/>
-              <a:t>Additional Presentation Tips</a:t>
+          <a:bodyPr wrap="square"/>
+          <a:lstStyle/>
+          <a:p>
+            <a:pPr>
+              <a:spcBef>
+                <a:spcPts val="300"/>
+              </a:spcBef>
+            </a:pPr>
+            <a:r>
+              <a:rPr sz="3400" b="0">
+                <a:solidFill>
+                  <a:srgbClr val="00853E"/>
+                </a:solidFill>
+              </a:rPr>
+              <a:t>Conclusion and Future Work</a:t>
             </a:r>
           </a:p>
         </p:txBody>
@@ -3470,46 +3602,158 @@
         </p:nvSpPr>
         <p:spPr/>
         <p:txBody>
-          <a:bodyPr>
+          <a:bodyPr wrap="square">
             <a:normAutofit/>
           </a:bodyPr>
           <a:lstStyle/>
           <a:p>
-            <a:r>
-              <a:rPr lang="en-US" dirty="0"/>
-              <a:t>Slide Design: Stick to this template </a:t>
-            </a:r>
-            <a:r>
-              <a:rPr lang="en-US" b="1" dirty="0"/>
-              <a:t>ONLY</a:t>
-            </a:r>
-            <a:r>
-              <a:rPr lang="en-US" dirty="0"/>
-              <a:t>. Avoid clutter; each slide should convey a single idea or a closely related set of points.</a:t>
-            </a:r>
-          </a:p>
-          <a:p>
-            <a:r>
-              <a:rPr lang="en-US" dirty="0"/>
-              <a:t>Limit text on each slide; use bullet points and visuals to enhance clarity.</a:t>
-            </a:r>
-          </a:p>
-          <a:p>
-            <a:r>
-              <a:rPr lang="en-US" dirty="0"/>
-              <a:t>Include diagrams, flowcharts, or tables where applicable.</a:t>
-            </a:r>
-          </a:p>
-          <a:p>
-            <a:r>
-              <a:rPr lang="en-US" dirty="0"/>
-              <a:t>Maintain a consistent theme and font size throughout the presentation.</a:t>
-            </a:r>
-          </a:p>
-          <a:p>
-            <a:r>
-              <a:rPr lang="en-US" dirty="0"/>
-              <a:t>Aim for a presentation length of 5-10 minutes.</a:t>
+            <a:pPr>
+              <a:spcBef>
+                <a:spcPts val="300"/>
+              </a:spcBef>
+            </a:pPr>
+            <a:r>
+              <a:rPr sz="2100" b="1">
+                <a:solidFill>
+                  <a:srgbClr val="00853E"/>
+                </a:solidFill>
+              </a:rPr>
+              <a:t>Key Conclusions</a:t>
+            </a:r>
+          </a:p>
+          <a:p>
+            <a:pPr lvl="1">
+              <a:spcBef>
+                <a:spcPts val="300"/>
+              </a:spcBef>
+            </a:pPr>
+            <a:r>
+              <a:rPr sz="1800" b="0">
+                <a:solidFill>
+                  <a:srgbClr val="000000"/>
+                </a:solidFill>
+              </a:rPr>
+              <a:t>Catch22 + LightGBM matches deep learning accuracy at a fraction of the cost</a:t>
+            </a:r>
+          </a:p>
+          <a:p>
+            <a:pPr lvl="1">
+              <a:spcBef>
+                <a:spcPts val="300"/>
+              </a:spcBef>
+            </a:pPr>
+            <a:r>
+              <a:rPr sz="1800" b="0">
+                <a:solidFill>
+                  <a:srgbClr val="000000"/>
+                </a:solidFill>
+              </a:rPr>
+              <a:t>Lag + Rolling Statistics are the strongest forecasting features (MSE −82%)</a:t>
+            </a:r>
+          </a:p>
+          <a:p>
+            <a:pPr lvl="1">
+              <a:spcBef>
+                <a:spcPts val="300"/>
+              </a:spcBef>
+            </a:pPr>
+            <a:r>
+              <a:rPr sz="1800" b="0">
+                <a:solidFill>
+                  <a:srgbClr val="000000"/>
+                </a:solidFill>
+              </a:rPr>
+              <a:t>SHAP-guided pruning reliably reduces dimensionality with zero accuracy loss</a:t>
+            </a:r>
+          </a:p>
+          <a:p>
+            <a:pPr lvl="1">
+              <a:spcBef>
+                <a:spcPts val="300"/>
+              </a:spcBef>
+            </a:pPr>
+            <a:r>
+              <a:rPr sz="1800" b="0">
+                <a:solidFill>
+                  <a:srgbClr val="000000"/>
+                </a:solidFill>
+              </a:rPr>
+              <a:t>Cross-domain generalization is limited when local timing is the discriminant</a:t>
+            </a:r>
+          </a:p>
+          <a:p>
+            <a:pPr>
+              <a:spcBef>
+                <a:spcPts val="300"/>
+              </a:spcBef>
+            </a:pPr>
+            <a:r>
+              <a:rPr sz="2100" b="1">
+                <a:solidFill>
+                  <a:srgbClr val="00853E"/>
+                </a:solidFill>
+              </a:rPr>
+              <a:t>Future Work</a:t>
+            </a:r>
+          </a:p>
+          <a:p>
+            <a:pPr lvl="1">
+              <a:spcBef>
+                <a:spcPts val="300"/>
+              </a:spcBef>
+            </a:pPr>
+            <a:r>
+              <a:rPr sz="1800" b="0">
+                <a:solidFill>
+                  <a:srgbClr val="000000"/>
+                </a:solidFill>
+              </a:rPr>
+              <a:t>LLM-assisted feature suggestion: use LLMs to propose domain-specific features</a:t>
+            </a:r>
+          </a:p>
+          <a:p>
+            <a:pPr lvl="1">
+              <a:spcBef>
+                <a:spcPts val="300"/>
+              </a:spcBef>
+            </a:pPr>
+            <a:r>
+              <a:rPr sz="1800" b="0">
+                <a:solidFill>
+                  <a:srgbClr val="000000"/>
+                </a:solidFill>
+              </a:rPr>
+              <a:t>Edge device deployment: ultra-lightweight Catch22 for real-time IoT sensors</a:t>
+            </a:r>
+          </a:p>
+          <a:p>
+            <a:pPr lvl="1">
+              <a:spcBef>
+                <a:spcPts val="300"/>
+              </a:spcBef>
+            </a:pPr>
+            <a:r>
+              <a:rPr sz="1800" b="0">
+                <a:solidFill>
+                  <a:srgbClr val="000000"/>
+                </a:solidFill>
+              </a:rPr>
+              <a:t>Validate on real WESAD wearable stress dataset (requires institutional access)</a:t>
+            </a:r>
+          </a:p>
+          <a:p>
+            <a:pPr lvl="1">
+              <a:spcBef>
+                <a:spcPts val="300"/>
+              </a:spcBef>
+            </a:pPr>
+            <a:r>
+              <a:rPr sz="1800" b="0">
+                <a:solidFill>
+                  <a:srgbClr val="000000"/>
+                </a:solidFill>
+              </a:rPr>
+              <a:t>XAI-first AutoML: make SHAP a primary optimization objective</a:t>
             </a:r>
           </a:p>
         </p:txBody>
@@ -3541,6 +3785,49 @@
               <a:t>14</a:t>
             </a:fld>
             <a:endParaRPr lang="en-US"/>
+          </a:p>
+        </p:txBody>
+      </p:sp>
+      <p:sp>
+        <p:nvSpPr>
+          <p:cNvPr id="5" name="Rectangle 4"/>
+          <p:cNvSpPr/>
+          <p:nvPr/>
+        </p:nvSpPr>
+        <p:spPr>
+          <a:xfrm>
+            <a:off x="0" y="1444752"/>
+            <a:ext cx="12188952" cy="50292"/>
+          </a:xfrm>
+          <a:prstGeom prst="rect">
+            <a:avLst/>
+          </a:prstGeom>
+          <a:solidFill>
+            <a:srgbClr val="00853E"/>
+          </a:solidFill>
+          <a:ln>
+            <a:noFill/>
+          </a:ln>
+        </p:spPr>
+        <p:style>
+          <a:lnRef idx="1">
+            <a:schemeClr val="accent1"/>
+          </a:lnRef>
+          <a:fillRef idx="3">
+            <a:schemeClr val="accent1"/>
+          </a:fillRef>
+          <a:effectRef idx="2">
+            <a:schemeClr val="accent1"/>
+          </a:effectRef>
+          <a:fontRef idx="minor">
+            <a:schemeClr val="lt1"/>
+          </a:fontRef>
+        </p:style>
+        <p:txBody>
+          <a:bodyPr rtlCol="0" anchor="ctr"/>
+          <a:lstStyle/>
+          <a:p>
+            <a:pPr algn="ctr"/>
           </a:p>
         </p:txBody>
       </p:sp>
@@ -3592,12 +3879,21 @@
         </p:nvSpPr>
         <p:spPr/>
         <p:txBody>
-          <a:bodyPr/>
-          <a:lstStyle/>
-          <a:p>
-            <a:r>
-              <a:rPr lang="en-US" dirty="0"/>
-              <a:t>Part 2: Live Demo of Implementation: Setup</a:t>
+          <a:bodyPr wrap="square"/>
+          <a:lstStyle/>
+          <a:p>
+            <a:pPr>
+              <a:spcBef>
+                <a:spcPts val="300"/>
+              </a:spcBef>
+            </a:pPr>
+            <a:r>
+              <a:rPr sz="3600" b="0">
+                <a:solidFill>
+                  <a:srgbClr val="00853E"/>
+                </a:solidFill>
+              </a:rPr>
+              <a:t>References</a:t>
             </a:r>
           </a:p>
         </p:txBody>
@@ -3620,18 +3916,96 @@
         </p:nvSpPr>
         <p:spPr/>
         <p:txBody>
-          <a:bodyPr/>
-          <a:lstStyle/>
-          <a:p>
-            <a:r>
-              <a:rPr lang="en-US" dirty="0"/>
-              <a:t>Prepare a Jupyter Notebook or other coding environment (e.g., Google Colab, PyCharm).</a:t>
-            </a:r>
-          </a:p>
-          <a:p>
-            <a:r>
-              <a:rPr lang="en-US" dirty="0"/>
-              <a:t>Ensure all dependencies are installed and tested before the demo.</a:t>
+          <a:bodyPr wrap="square"/>
+          <a:lstStyle/>
+          <a:p>
+            <a:pPr>
+              <a:spcBef>
+                <a:spcPts val="300"/>
+              </a:spcBef>
+            </a:pPr>
+            <a:r>
+              <a:rPr sz="1500" b="0">
+                <a:solidFill>
+                  <a:srgbClr val="000000"/>
+                </a:solidFill>
+              </a:rPr>
+              <a:t>[1] H. Badi, G. Forestier, and J. Weber, "COCALITE: A Hybrid Approach for Time Series Classification Using Catch22 and LITE," in 2024 IEEE BigData, pp. 5234–5243.</a:t>
+            </a:r>
+          </a:p>
+          <a:p>
+            <a:pPr>
+              <a:spcBef>
+                <a:spcPts val="300"/>
+              </a:spcBef>
+            </a:pPr>
+            <a:r>
+              <a:rPr sz="1500" b="0">
+                <a:solidFill>
+                  <a:srgbClr val="000000"/>
+                </a:solidFill>
+              </a:rPr>
+              <a:t>[2] M. D'Aversa, F. Giannini, and M. Scardapane, "SPLiT: Spatio-Temporal Linear Model Trees for Multi-Step Time Series Forecasting," in 2024 IEEE BigData, pp. 3412–3421.</a:t>
+            </a:r>
+          </a:p>
+          <a:p>
+            <a:pPr>
+              <a:spcBef>
+                <a:spcPts val="300"/>
+              </a:spcBef>
+            </a:pPr>
+            <a:r>
+              <a:rPr sz="1500" b="0">
+                <a:solidFill>
+                  <a:srgbClr val="000000"/>
+                </a:solidFill>
+              </a:rPr>
+              <a:t>[3] L. Valerio, A. Passarella, and M. Conti, "Unsupervised Anomaly Detection in Wearable PPG Data via Catch22 Features," in 2024 IEEE SENSORS, pp. 1–4.</a:t>
+            </a:r>
+          </a:p>
+          <a:p>
+            <a:pPr>
+              <a:spcBef>
+                <a:spcPts val="300"/>
+              </a:spcBef>
+            </a:pPr>
+            <a:r>
+              <a:rPr sz="1500" b="0">
+                <a:solidFill>
+                  <a:srgbClr val="000000"/>
+                </a:solidFill>
+              </a:rPr>
+              <a:t>[4] T. Okadome and J. Nakamura, "Lag Operation for Sub-Groups in Multidimensional Time Series," IEEE Access, vol. 12, pp. 15432–15445, 2024.</a:t>
+            </a:r>
+          </a:p>
+          <a:p>
+            <a:pPr>
+              <a:spcBef>
+                <a:spcPts val="300"/>
+              </a:spcBef>
+            </a:pPr>
+            <a:r>
+              <a:rPr sz="1500" b="0">
+                <a:solidFill>
+                  <a:srgbClr val="000000"/>
+                </a:solidFill>
+              </a:rPr>
+              <a:t>[5] O. Petrosian, D. Wang, and S. Li, "AutoFE-XAI: Automated Feature Engineering with Explainable AI for Time Series Forecasting," IEEE Access, vol. 13, pp. 2109–2120, 2025.</a:t>
+            </a:r>
+          </a:p>
+          <a:p>
+            <a:pPr>
+              <a:spcBef>
+                <a:spcPts val="300"/>
+              </a:spcBef>
+            </a:pPr>
+            <a:r>
+              <a:rPr sz="1500" b="0">
+                <a:solidFill>
+                  <a:srgbClr val="000000"/>
+                </a:solidFill>
+              </a:rPr>
+              <a:t>[6] C. H. Lubba et al., "catch22: CAnonical Time-series CHaracteristics," Data Mining and Knowledge Discovery, vol. 33, no. 6, pp. 1821–1852, 2019.</a:t>
             </a:r>
           </a:p>
         </p:txBody>
@@ -3662,6 +4036,49 @@
               <a:t>15</a:t>
             </a:fld>
             <a:endParaRPr lang="en-US"/>
+          </a:p>
+        </p:txBody>
+      </p:sp>
+      <p:sp>
+        <p:nvSpPr>
+          <p:cNvPr id="5" name="Rectangle 4"/>
+          <p:cNvSpPr/>
+          <p:nvPr/>
+        </p:nvSpPr>
+        <p:spPr>
+          <a:xfrm>
+            <a:off x="0" y="1444752"/>
+            <a:ext cx="12188952" cy="50292"/>
+          </a:xfrm>
+          <a:prstGeom prst="rect">
+            <a:avLst/>
+          </a:prstGeom>
+          <a:solidFill>
+            <a:srgbClr val="00853E"/>
+          </a:solidFill>
+          <a:ln>
+            <a:noFill/>
+          </a:ln>
+        </p:spPr>
+        <p:style>
+          <a:lnRef idx="1">
+            <a:schemeClr val="accent1"/>
+          </a:lnRef>
+          <a:fillRef idx="3">
+            <a:schemeClr val="accent1"/>
+          </a:fillRef>
+          <a:effectRef idx="2">
+            <a:schemeClr val="accent1"/>
+          </a:effectRef>
+          <a:fontRef idx="minor">
+            <a:schemeClr val="lt1"/>
+          </a:fontRef>
+        </p:style>
+        <p:txBody>
+          <a:bodyPr rtlCol="0" anchor="ctr"/>
+          <a:lstStyle/>
+          <a:p>
+            <a:pPr algn="ctr"/>
           </a:p>
         </p:txBody>
       </p:sp>
@@ -3713,12 +4130,21 @@
         </p:nvSpPr>
         <p:spPr/>
         <p:txBody>
-          <a:bodyPr/>
-          <a:lstStyle/>
-          <a:p>
-            <a:r>
-              <a:rPr lang="en-US" dirty="0"/>
-              <a:t>Flow of the Demo</a:t>
+          <a:bodyPr wrap="square"/>
+          <a:lstStyle/>
+          <a:p>
+            <a:pPr>
+              <a:spcBef>
+                <a:spcPts val="300"/>
+              </a:spcBef>
+            </a:pPr>
+            <a:r>
+              <a:rPr sz="4800" b="0">
+                <a:solidFill>
+                  <a:srgbClr val="00853E"/>
+                </a:solidFill>
+              </a:rPr>
+              <a:t>Thank You!</a:t>
             </a:r>
           </a:p>
         </p:txBody>
@@ -3803,6 +4229,176 @@
               <a:t>16</a:t>
             </a:fld>
             <a:endParaRPr lang="en-US"/>
+          </a:p>
+        </p:txBody>
+      </p:sp>
+      <p:sp>
+        <p:nvSpPr>
+          <p:cNvPr id="5" name="TextBox 4"/>
+          <p:cNvSpPr txBox="1"/>
+          <p:nvPr/>
+        </p:nvSpPr>
+        <p:spPr>
+          <a:xfrm>
+            <a:off x="1371600" y="2743200"/>
+            <a:ext cx="9445752" cy="502920"/>
+          </a:xfrm>
+          <a:prstGeom prst="rect">
+            <a:avLst/>
+          </a:prstGeom>
+          <a:noFill/>
+        </p:spPr>
+        <p:txBody>
+          <a:bodyPr wrap="square">
+            <a:spAutoFit/>
+          </a:bodyPr>
+          <a:lstStyle/>
+          <a:p>
+            <a:pPr algn="ctr"/>
+            <a:r>
+              <a:rPr sz="2400" b="0">
+                <a:solidFill>
+                  <a:srgbClr val="444444"/>
+                </a:solidFill>
+              </a:rPr>
+              <a:t>Questions &amp; Discussion</a:t>
+            </a:r>
+          </a:p>
+        </p:txBody>
+      </p:sp>
+      <p:sp>
+        <p:nvSpPr>
+          <p:cNvPr id="6" name="TextBox 5"/>
+          <p:cNvSpPr txBox="1"/>
+          <p:nvPr/>
+        </p:nvSpPr>
+        <p:spPr>
+          <a:xfrm>
+            <a:off x="1371600" y="3383280"/>
+            <a:ext cx="9445752" cy="411480"/>
+          </a:xfrm>
+          <a:prstGeom prst="rect">
+            <a:avLst/>
+          </a:prstGeom>
+          <a:noFill/>
+        </p:spPr>
+        <p:txBody>
+          <a:bodyPr wrap="square">
+            <a:spAutoFit/>
+          </a:bodyPr>
+          <a:lstStyle/>
+          <a:p>
+            <a:pPr algn="ctr"/>
+            <a:r>
+              <a:rPr sz="1700" b="0">
+                <a:solidFill>
+                  <a:srgbClr val="000000"/>
+                </a:solidFill>
+              </a:rPr>
+              <a:t>Ashish Rathnakar Shetty  ·  ashishrathnakarshetty@unt.edu</a:t>
+            </a:r>
+          </a:p>
+        </p:txBody>
+      </p:sp>
+      <p:sp>
+        <p:nvSpPr>
+          <p:cNvPr id="7" name="TextBox 6"/>
+          <p:cNvSpPr txBox="1"/>
+          <p:nvPr/>
+        </p:nvSpPr>
+        <p:spPr>
+          <a:xfrm>
+            <a:off x="1371600" y="3840480"/>
+            <a:ext cx="9445752" cy="411480"/>
+          </a:xfrm>
+          <a:prstGeom prst="rect">
+            <a:avLst/>
+          </a:prstGeom>
+          <a:noFill/>
+        </p:spPr>
+        <p:txBody>
+          <a:bodyPr wrap="square">
+            <a:spAutoFit/>
+          </a:bodyPr>
+          <a:lstStyle/>
+          <a:p>
+            <a:pPr algn="ctr"/>
+            <a:r>
+              <a:rPr sz="1700" b="0">
+                <a:solidFill>
+                  <a:srgbClr val="000000"/>
+                </a:solidFill>
+              </a:rPr>
+              <a:t>Kushal Sai Venigalla  ·  KushalSaiVenigalla@unt.edu</a:t>
+            </a:r>
+          </a:p>
+        </p:txBody>
+      </p:sp>
+      <p:sp>
+        <p:nvSpPr>
+          <p:cNvPr id="8" name="TextBox 7"/>
+          <p:cNvSpPr txBox="1"/>
+          <p:nvPr/>
+        </p:nvSpPr>
+        <p:spPr>
+          <a:xfrm>
+            <a:off x="1371600" y="4434840"/>
+            <a:ext cx="9445752" cy="411480"/>
+          </a:xfrm>
+          <a:prstGeom prst="rect">
+            <a:avLst/>
+          </a:prstGeom>
+          <a:noFill/>
+        </p:spPr>
+        <p:txBody>
+          <a:bodyPr wrap="square">
+            <a:spAutoFit/>
+          </a:bodyPr>
+          <a:lstStyle/>
+          <a:p>
+            <a:pPr algn="ctr"/>
+            <a:r>
+              <a:rPr sz="1500" b="0">
+                <a:solidFill>
+                  <a:srgbClr val="00853E"/>
+                </a:solidFill>
+              </a:rPr>
+              <a:t>GitHub: github.com/Ash-projects-personal/CSCE5222-Group18-FeatureEngineering</a:t>
+            </a:r>
+          </a:p>
+        </p:txBody>
+      </p:sp>
+      <p:sp>
+        <p:nvSpPr>
+          <p:cNvPr id="9" name="TextBox 8"/>
+          <p:cNvSpPr txBox="1"/>
+          <p:nvPr/>
+        </p:nvSpPr>
+        <p:spPr>
+          <a:xfrm>
+            <a:off x="1371600" y="4937760"/>
+            <a:ext cx="9445752" cy="365760"/>
+          </a:xfrm>
+          <a:prstGeom prst="rect">
+            <a:avLst/>
+          </a:prstGeom>
+          <a:noFill/>
+        </p:spPr>
+        <p:txBody>
+          <a:bodyPr wrap="square">
+            <a:spAutoFit/>
+          </a:bodyPr>
+          <a:lstStyle/>
+          <a:p>
+            <a:pPr algn="ctr"/>
+            <a:r>
+              <a:rPr sz="1400" b="0">
+                <a:solidFill>
+                  <a:srgbClr val="444444"/>
+                </a:solidFill>
+              </a:rPr>
+              <a:t>CSCE 5222 Feature Engineering  |  Group 18  |  University of North Texas</a:t>
+            </a:r>
           </a:p>
         </p:txBody>
       </p:sp>
@@ -3856,12 +4452,7 @@
         <p:txBody>
           <a:bodyPr/>
           <a:lstStyle/>
-          <a:p>
-            <a:r>
-              <a:rPr lang="en-US" dirty="0"/>
-              <a:t>Interactivity</a:t>
-            </a:r>
-          </a:p>
+          <a:p/>
         </p:txBody>
       </p:sp>
       <p:sp>
@@ -3884,18 +4475,7 @@
         <p:txBody>
           <a:bodyPr/>
           <a:lstStyle/>
-          <a:p>
-            <a:r>
-              <a:rPr lang="en-US" dirty="0"/>
-              <a:t>Highlight key parts of the code and explain the logic behind them.</a:t>
-            </a:r>
-          </a:p>
-          <a:p>
-            <a:r>
-              <a:rPr lang="en-US" dirty="0"/>
-              <a:t>Use visualizations (e.g., plots, tables) to make results easy to understand.</a:t>
-            </a:r>
-          </a:p>
+          <a:p/>
         </p:txBody>
       </p:sp>
       <p:sp>
@@ -3977,12 +4557,7 @@
         <p:txBody>
           <a:bodyPr/>
           <a:lstStyle/>
-          <a:p>
-            <a:r>
-              <a:rPr lang="en-US" dirty="0"/>
-              <a:t>Tips for the Demo</a:t>
-            </a:r>
-          </a:p>
+          <a:p/>
         </p:txBody>
       </p:sp>
       <p:sp>
@@ -4007,49 +4582,7 @@
             <a:normAutofit lnSpcReduction="10000"/>
           </a:bodyPr>
           <a:lstStyle/>
-          <a:p>
-            <a:r>
-              <a:rPr lang="en-US" dirty="0"/>
-              <a:t>Use concise and well-organized slides to complement the live demo.</a:t>
-            </a:r>
-          </a:p>
-          <a:p>
-            <a:r>
-              <a:rPr lang="en-US" dirty="0"/>
-              <a:t>Avoid technical jargon; explain concepts clearly for a general audience.</a:t>
-            </a:r>
-          </a:p>
-          <a:p>
-            <a:r>
-              <a:rPr lang="en-US" dirty="0"/>
-              <a:t>Test the demo environment multiple times to prevent unexpected issues.</a:t>
-            </a:r>
-          </a:p>
-          <a:p>
-            <a:r>
-              <a:rPr lang="en-US" dirty="0"/>
-              <a:t>Prepare backup screenshots or videos in case of technical difficulties.</a:t>
-            </a:r>
-          </a:p>
-          <a:p>
-            <a:r>
-              <a:rPr lang="en-US" dirty="0"/>
-              <a:t>Aim for a demo length of 5-10 minutes.</a:t>
-            </a:r>
-          </a:p>
-          <a:p>
-            <a:r>
-              <a:rPr lang="en-US" dirty="0">
-                <a:highlight>
-                  <a:srgbClr val="FFFF00"/>
-                </a:highlight>
-              </a:rPr>
-              <a:t>If the demo is longer than 9 minutes, record a video and play it at a faster speed while providing a live explanation to keep the audience engaged.</a:t>
-            </a:r>
-          </a:p>
-          <a:p>
-            <a:endParaRPr lang="en-US" dirty="0"/>
-          </a:p>
+          <a:p/>
         </p:txBody>
       </p:sp>
       <p:sp>
@@ -4131,12 +4664,7 @@
         <p:txBody>
           <a:bodyPr/>
           <a:lstStyle/>
-          <a:p>
-            <a:r>
-              <a:rPr lang="en-US" dirty="0"/>
-              <a:t>Feedback</a:t>
-            </a:r>
-          </a:p>
+          <a:p/>
         </p:txBody>
       </p:sp>
       <p:sp>
@@ -4159,26 +4687,7 @@
         <p:txBody>
           <a:bodyPr/>
           <a:lstStyle/>
-          <a:p>
-            <a:r>
-              <a:rPr lang="en-US" dirty="0"/>
-              <a:t>Feedback Reports  </a:t>
-            </a:r>
-          </a:p>
-          <a:p>
-            <a:pPr lvl="1"/>
-            <a:r>
-              <a:rPr lang="en-US" dirty="0"/>
-              <a:t>Submit feedback reports for other groups’ presentations on the same day (maximum 500 words total for two presentations). The number of reports required will be announced at the beginning of each day.</a:t>
-            </a:r>
-          </a:p>
-          <a:p>
-            <a:pPr lvl="1"/>
-            <a:r>
-              <a:rPr lang="en-US" dirty="0"/>
-              <a:t>Each feedback report is worth 10 points and will be counted toward the Project 2 Report. </a:t>
-            </a:r>
-          </a:p>
+          <a:p/>
         </p:txBody>
       </p:sp>
       <p:sp>
@@ -4535,528 +5044,6 @@
         <p14:creationId xmlns:p14="http://schemas.microsoft.com/office/powerpoint/2010/main" val="4173215154"/>
       </p:ext>
     </p:extLst>
-  </p:cSld>
-  <p:clrMapOvr>
-    <a:masterClrMapping/>
-  </p:clrMapOvr>
-</p:sld>
-</file>
-
-<file path=ppt/slides/slide20.xml><?xml version="1.0" encoding="utf-8"?>
-<p:sld xmlns:a="http://schemas.openxmlformats.org/drawingml/2006/main" xmlns:p="http://schemas.openxmlformats.org/presentationml/2006/main" xmlns:r="http://schemas.openxmlformats.org/officeDocument/2006/relationships">
-  <p:cSld>
-    <p:spTree>
-      <p:nvGrpSpPr>
-        <p:cNvPr id="1" name=""/>
-        <p:cNvGrpSpPr/>
-        <p:nvPr/>
-      </p:nvGrpSpPr>
-      <p:grpSpPr/>
-      <p:sp>
-        <p:nvSpPr>
-          <p:cNvPr id="2" name="Title 1"/>
-          <p:cNvSpPr>
-            <a:spLocks noGrp="1"/>
-          </p:cNvSpPr>
-          <p:nvPr>
-            <p:ph type="title"/>
-          </p:nvPr>
-        </p:nvSpPr>
-        <p:spPr/>
-        <p:txBody>
-          <a:bodyPr wrap="square"/>
-          <a:lstStyle/>
-          <a:p>
-            <a:pPr>
-              <a:spcBef>
-                <a:spcPts val="300"/>
-              </a:spcBef>
-            </a:pPr>
-            <a:r>
-              <a:rPr sz="3400" b="0">
-                <a:solidFill>
-                  <a:srgbClr val="00853E"/>
-                </a:solidFill>
-              </a:rPr>
-              <a:t>Conclusion and Future Work</a:t>
-            </a:r>
-          </a:p>
-        </p:txBody>
-      </p:sp>
-      <p:sp>
-        <p:nvSpPr>
-          <p:cNvPr id="3" name="Content Placeholder 2"/>
-          <p:cNvSpPr>
-            <a:spLocks noGrp="1"/>
-          </p:cNvSpPr>
-          <p:nvPr>
-            <p:ph idx="1"/>
-          </p:nvPr>
-        </p:nvSpPr>
-        <p:spPr/>
-        <p:txBody>
-          <a:bodyPr wrap="square"/>
-          <a:lstStyle/>
-          <a:p>
-            <a:pPr>
-              <a:spcBef>
-                <a:spcPts val="300"/>
-              </a:spcBef>
-            </a:pPr>
-            <a:r>
-              <a:rPr sz="2100" b="1">
-                <a:solidFill>
-                  <a:srgbClr val="00853E"/>
-                </a:solidFill>
-              </a:rPr>
-              <a:t>Key Conclusions</a:t>
-            </a:r>
-          </a:p>
-          <a:p>
-            <a:pPr lvl="1">
-              <a:spcBef>
-                <a:spcPts val="300"/>
-              </a:spcBef>
-            </a:pPr>
-            <a:r>
-              <a:rPr sz="1800" b="0">
-                <a:solidFill>
-                  <a:srgbClr val="000000"/>
-                </a:solidFill>
-              </a:rPr>
-              <a:t>Catch22 + LightGBM matches deep learning accuracy at a fraction of the cost</a:t>
-            </a:r>
-          </a:p>
-          <a:p>
-            <a:pPr lvl="1">
-              <a:spcBef>
-                <a:spcPts val="300"/>
-              </a:spcBef>
-            </a:pPr>
-            <a:r>
-              <a:rPr sz="1800" b="0">
-                <a:solidFill>
-                  <a:srgbClr val="000000"/>
-                </a:solidFill>
-              </a:rPr>
-              <a:t>Lag + Rolling Statistics are the strongest forecasting features (MSE −82%)</a:t>
-            </a:r>
-          </a:p>
-          <a:p>
-            <a:pPr lvl="1">
-              <a:spcBef>
-                <a:spcPts val="300"/>
-              </a:spcBef>
-            </a:pPr>
-            <a:r>
-              <a:rPr sz="1800" b="0">
-                <a:solidFill>
-                  <a:srgbClr val="000000"/>
-                </a:solidFill>
-              </a:rPr>
-              <a:t>SHAP-guided pruning reliably reduces dimensionality with zero accuracy loss</a:t>
-            </a:r>
-          </a:p>
-          <a:p>
-            <a:pPr lvl="1">
-              <a:spcBef>
-                <a:spcPts val="300"/>
-              </a:spcBef>
-            </a:pPr>
-            <a:r>
-              <a:rPr sz="1800" b="0">
-                <a:solidFill>
-                  <a:srgbClr val="000000"/>
-                </a:solidFill>
-              </a:rPr>
-              <a:t>Cross-domain generalization is limited when local timing is the discriminant</a:t>
-            </a:r>
-          </a:p>
-          <a:p>
-            <a:pPr>
-              <a:spcBef>
-                <a:spcPts val="300"/>
-              </a:spcBef>
-            </a:pPr>
-            <a:r>
-              <a:rPr sz="2100" b="1">
-                <a:solidFill>
-                  <a:srgbClr val="00853E"/>
-                </a:solidFill>
-              </a:rPr>
-              <a:t>Future Work</a:t>
-            </a:r>
-          </a:p>
-          <a:p>
-            <a:pPr lvl="1">
-              <a:spcBef>
-                <a:spcPts val="300"/>
-              </a:spcBef>
-            </a:pPr>
-            <a:r>
-              <a:rPr sz="1800" b="0">
-                <a:solidFill>
-                  <a:srgbClr val="000000"/>
-                </a:solidFill>
-              </a:rPr>
-              <a:t>LLM-assisted feature suggestion: use LLMs to propose domain-specific features</a:t>
-            </a:r>
-          </a:p>
-          <a:p>
-            <a:pPr lvl="1">
-              <a:spcBef>
-                <a:spcPts val="300"/>
-              </a:spcBef>
-            </a:pPr>
-            <a:r>
-              <a:rPr sz="1800" b="0">
-                <a:solidFill>
-                  <a:srgbClr val="000000"/>
-                </a:solidFill>
-              </a:rPr>
-              <a:t>Edge device deployment: ultra-lightweight Catch22 for real-time IoT sensors</a:t>
-            </a:r>
-          </a:p>
-          <a:p>
-            <a:pPr lvl="1">
-              <a:spcBef>
-                <a:spcPts val="300"/>
-              </a:spcBef>
-            </a:pPr>
-            <a:r>
-              <a:rPr sz="1800" b="0">
-                <a:solidFill>
-                  <a:srgbClr val="000000"/>
-                </a:solidFill>
-              </a:rPr>
-              <a:t>Validate on real WESAD wearable stress dataset (requires institutional access)</a:t>
-            </a:r>
-          </a:p>
-          <a:p>
-            <a:pPr lvl="1">
-              <a:spcBef>
-                <a:spcPts val="300"/>
-              </a:spcBef>
-            </a:pPr>
-            <a:r>
-              <a:rPr sz="1800" b="0">
-                <a:solidFill>
-                  <a:srgbClr val="000000"/>
-                </a:solidFill>
-              </a:rPr>
-              <a:t>XAI-first AutoML: make SHAP a primary optimization objective</a:t>
-            </a:r>
-          </a:p>
-        </p:txBody>
-      </p:sp>
-      <p:sp>
-        <p:nvSpPr>
-          <p:cNvPr id="4" name="Rectangle 3"/>
-          <p:cNvSpPr/>
-          <p:nvPr/>
-        </p:nvSpPr>
-        <p:spPr>
-          <a:xfrm>
-            <a:off x="0" y="1444752"/>
-            <a:ext cx="12188952" cy="50292"/>
-          </a:xfrm>
-          <a:prstGeom prst="rect">
-            <a:avLst/>
-          </a:prstGeom>
-          <a:solidFill>
-            <a:srgbClr val="00853E"/>
-          </a:solidFill>
-          <a:ln>
-            <a:noFill/>
-          </a:ln>
-        </p:spPr>
-        <p:style>
-          <a:lnRef idx="1">
-            <a:schemeClr val="accent1"/>
-          </a:lnRef>
-          <a:fillRef idx="3">
-            <a:schemeClr val="accent1"/>
-          </a:fillRef>
-          <a:effectRef idx="2">
-            <a:schemeClr val="accent1"/>
-          </a:effectRef>
-          <a:fontRef idx="minor">
-            <a:schemeClr val="lt1"/>
-          </a:fontRef>
-        </p:style>
-        <p:txBody>
-          <a:bodyPr rtlCol="0" anchor="ctr"/>
-          <a:lstStyle/>
-          <a:p>
-            <a:pPr algn="ctr"/>
-          </a:p>
-        </p:txBody>
-      </p:sp>
-    </p:spTree>
-  </p:cSld>
-  <p:clrMapOvr>
-    <a:masterClrMapping/>
-  </p:clrMapOvr>
-</p:sld>
-</file>
-
-<file path=ppt/slides/slide21.xml><?xml version="1.0" encoding="utf-8"?>
-<p:sld xmlns:a="http://schemas.openxmlformats.org/drawingml/2006/main" xmlns:p="http://schemas.openxmlformats.org/presentationml/2006/main" xmlns:r="http://schemas.openxmlformats.org/officeDocument/2006/relationships">
-  <p:cSld>
-    <p:spTree>
-      <p:nvGrpSpPr>
-        <p:cNvPr id="1" name=""/>
-        <p:cNvGrpSpPr/>
-        <p:nvPr/>
-      </p:nvGrpSpPr>
-      <p:grpSpPr/>
-      <p:sp>
-        <p:nvSpPr>
-          <p:cNvPr id="2" name="Title 1"/>
-          <p:cNvSpPr>
-            <a:spLocks noGrp="1"/>
-          </p:cNvSpPr>
-          <p:nvPr>
-            <p:ph type="title"/>
-          </p:nvPr>
-        </p:nvSpPr>
-        <p:spPr/>
-        <p:txBody>
-          <a:bodyPr wrap="square"/>
-          <a:lstStyle/>
-          <a:p>
-            <a:pPr>
-              <a:spcBef>
-                <a:spcPts val="300"/>
-              </a:spcBef>
-            </a:pPr>
-            <a:r>
-              <a:rPr sz="3600" b="0">
-                <a:solidFill>
-                  <a:srgbClr val="00853E"/>
-                </a:solidFill>
-              </a:rPr>
-              <a:t>References</a:t>
-            </a:r>
-          </a:p>
-        </p:txBody>
-      </p:sp>
-      <p:sp>
-        <p:nvSpPr>
-          <p:cNvPr id="3" name="Content Placeholder 2"/>
-          <p:cNvSpPr>
-            <a:spLocks noGrp="1"/>
-          </p:cNvSpPr>
-          <p:nvPr>
-            <p:ph idx="1"/>
-          </p:nvPr>
-        </p:nvSpPr>
-        <p:spPr/>
-        <p:txBody>
-          <a:bodyPr wrap="square"/>
-          <a:lstStyle/>
-          <a:p>
-            <a:pPr>
-              <a:spcBef>
-                <a:spcPts val="300"/>
-              </a:spcBef>
-            </a:pPr>
-            <a:r>
-              <a:rPr sz="1500" b="0">
-                <a:solidFill>
-                  <a:srgbClr val="000000"/>
-                </a:solidFill>
-              </a:rPr>
-              <a:t>[1] H. Badi, G. Forestier, and J. Weber, "COCALITE: A Hybrid Approach for Time Series Classification Using Catch22 and LITE," in 2024 IEEE BigData, pp. 5234–5243.</a:t>
-            </a:r>
-          </a:p>
-          <a:p>
-            <a:pPr>
-              <a:spcBef>
-                <a:spcPts val="300"/>
-              </a:spcBef>
-            </a:pPr>
-            <a:r>
-              <a:rPr sz="1500" b="0">
-                <a:solidFill>
-                  <a:srgbClr val="000000"/>
-                </a:solidFill>
-              </a:rPr>
-              <a:t>[2] M. D'Aversa, F. Giannini, and M. Scardapane, "SPLiT: Spatio-Temporal Linear Model Trees for Multi-Step Time Series Forecasting," in 2024 IEEE BigData, pp. 3412–3421.</a:t>
-            </a:r>
-          </a:p>
-          <a:p>
-            <a:pPr>
-              <a:spcBef>
-                <a:spcPts val="300"/>
-              </a:spcBef>
-            </a:pPr>
-            <a:r>
-              <a:rPr sz="1500" b="0">
-                <a:solidFill>
-                  <a:srgbClr val="000000"/>
-                </a:solidFill>
-              </a:rPr>
-              <a:t>[3] L. Valerio, A. Passarella, and M. Conti, "Unsupervised Anomaly Detection in Wearable PPG Data via Catch22 Features," in 2024 IEEE SENSORS, pp. 1–4.</a:t>
-            </a:r>
-          </a:p>
-          <a:p>
-            <a:pPr>
-              <a:spcBef>
-                <a:spcPts val="300"/>
-              </a:spcBef>
-            </a:pPr>
-            <a:r>
-              <a:rPr sz="1500" b="0">
-                <a:solidFill>
-                  <a:srgbClr val="000000"/>
-                </a:solidFill>
-              </a:rPr>
-              <a:t>[4] T. Okadome and J. Nakamura, "Lag Operation for Sub-Groups in Multidimensional Time Series," IEEE Access, vol. 12, pp. 15432–15445, 2024.</a:t>
-            </a:r>
-          </a:p>
-          <a:p>
-            <a:pPr>
-              <a:spcBef>
-                <a:spcPts val="300"/>
-              </a:spcBef>
-            </a:pPr>
-            <a:r>
-              <a:rPr sz="1500" b="0">
-                <a:solidFill>
-                  <a:srgbClr val="000000"/>
-                </a:solidFill>
-              </a:rPr>
-              <a:t>[5] O. Petrosian, D. Wang, and S. Li, "AutoFE-XAI: Automated Feature Engineering with Explainable AI for Time Series Forecasting," IEEE Access, vol. 13, pp. 2109–2120, 2025.</a:t>
-            </a:r>
-          </a:p>
-          <a:p>
-            <a:pPr>
-              <a:spcBef>
-                <a:spcPts val="300"/>
-              </a:spcBef>
-            </a:pPr>
-            <a:r>
-              <a:rPr sz="1500" b="0">
-                <a:solidFill>
-                  <a:srgbClr val="000000"/>
-                </a:solidFill>
-              </a:rPr>
-              <a:t>[6] C. H. Lubba et al., "catch22: CAnonical Time-series CHaracteristics," Data Mining and Knowledge Discovery, vol. 33, no. 6, pp. 1821–1852, 2019.</a:t>
-            </a:r>
-          </a:p>
-        </p:txBody>
-      </p:sp>
-      <p:sp>
-        <p:nvSpPr>
-          <p:cNvPr id="4" name="Rectangle 3"/>
-          <p:cNvSpPr/>
-          <p:nvPr/>
-        </p:nvSpPr>
-        <p:spPr>
-          <a:xfrm>
-            <a:off x="0" y="1444752"/>
-            <a:ext cx="12188952" cy="50292"/>
-          </a:xfrm>
-          <a:prstGeom prst="rect">
-            <a:avLst/>
-          </a:prstGeom>
-          <a:solidFill>
-            <a:srgbClr val="00853E"/>
-          </a:solidFill>
-          <a:ln>
-            <a:noFill/>
-          </a:ln>
-        </p:spPr>
-        <p:style>
-          <a:lnRef idx="1">
-            <a:schemeClr val="accent1"/>
-          </a:lnRef>
-          <a:fillRef idx="3">
-            <a:schemeClr val="accent1"/>
-          </a:fillRef>
-          <a:effectRef idx="2">
-            <a:schemeClr val="accent1"/>
-          </a:effectRef>
-          <a:fontRef idx="minor">
-            <a:schemeClr val="lt1"/>
-          </a:fontRef>
-        </p:style>
-        <p:txBody>
-          <a:bodyPr rtlCol="0" anchor="ctr"/>
-          <a:lstStyle/>
-          <a:p>
-            <a:pPr algn="ctr"/>
-          </a:p>
-        </p:txBody>
-      </p:sp>
-    </p:spTree>
-  </p:cSld>
-  <p:clrMapOvr>
-    <a:masterClrMapping/>
-  </p:clrMapOvr>
-</p:sld>
-</file>
-
-<file path=ppt/slides/slide22.xml><?xml version="1.0" encoding="utf-8"?>
-<p:sld xmlns:a="http://schemas.openxmlformats.org/drawingml/2006/main" xmlns:p="http://schemas.openxmlformats.org/presentationml/2006/main" xmlns:r="http://schemas.openxmlformats.org/officeDocument/2006/relationships">
-  <p:cSld>
-    <p:spTree>
-      <p:nvGrpSpPr>
-        <p:cNvPr id="1" name=""/>
-        <p:cNvGrpSpPr/>
-        <p:nvPr/>
-      </p:nvGrpSpPr>
-      <p:grpSpPr/>
-      <p:sp>
-        <p:nvSpPr>
-          <p:cNvPr id="2" name="Title 1"/>
-          <p:cNvSpPr>
-            <a:spLocks noGrp="1"/>
-          </p:cNvSpPr>
-          <p:nvPr>
-            <p:ph type="ctrTitle"/>
-          </p:nvPr>
-        </p:nvSpPr>
-        <p:spPr/>
-        <p:txBody>
-          <a:bodyPr wrap="square"/>
-          <a:lstStyle/>
-          <a:p>
-            <a:pPr>
-              <a:spcBef>
-                <a:spcPts val="300"/>
-              </a:spcBef>
-            </a:pPr>
-            <a:r>
-              <a:rPr sz="4800" b="0">
-                <a:solidFill>
-                  <a:srgbClr val="00853E"/>
-                </a:solidFill>
-              </a:rPr>
-              <a:t>Thank You!</a:t>
-            </a:r>
-          </a:p>
-        </p:txBody>
-      </p:sp>
-      <p:sp>
-        <p:nvSpPr>
-          <p:cNvPr id="3" name="Subtitle 2"/>
-          <p:cNvSpPr>
-            <a:spLocks noGrp="1"/>
-          </p:cNvSpPr>
-          <p:nvPr>
-            <p:ph type="subTitle" idx="1"/>
-          </p:nvPr>
-        </p:nvSpPr>
-        <p:spPr/>
-        <p:txBody>
-          <a:bodyPr/>
-          <a:lstStyle/>
-          <a:p/>
-        </p:txBody>
-      </p:sp>
-    </p:spTree>
   </p:cSld>
   <p:clrMapOvr>
     <a:masterClrMapping/>
@@ -6672,6 +6659,7 @@
           </a:bodyPr>
           <a:lstStyle/>
           <a:p>
+            <a:pPr algn="l"/>
             <a:r>
               <a:rPr sz="1700" b="1">
                 <a:solidFill>
@@ -6705,6 +6693,7 @@
           </a:bodyPr>
           <a:lstStyle/>
           <a:p>
+            <a:pPr algn="l"/>
             <a:r>
               <a:rPr sz="1500" b="0">
                 <a:solidFill>
@@ -6724,7 +6713,7 @@
         </p:nvSpPr>
         <p:spPr>
           <a:xfrm>
-            <a:off x="8321040" y="2542032"/>
+            <a:off x="8321040" y="2560320"/>
             <a:ext cx="3657600" cy="411480"/>
           </a:xfrm>
           <a:prstGeom prst="rect">
@@ -6738,6 +6727,7 @@
           </a:bodyPr>
           <a:lstStyle/>
           <a:p>
+            <a:pPr algn="l"/>
             <a:r>
               <a:rPr sz="1500" b="0">
                 <a:solidFill>
@@ -6757,7 +6747,7 @@
         </p:nvSpPr>
         <p:spPr>
           <a:xfrm>
-            <a:off x="8321040" y="2980944"/>
+            <a:off x="8321040" y="3017520"/>
             <a:ext cx="3657600" cy="411480"/>
           </a:xfrm>
           <a:prstGeom prst="rect">
@@ -6771,6 +6761,7 @@
           </a:bodyPr>
           <a:lstStyle/>
           <a:p>
+            <a:pPr algn="l"/>
             <a:r>
               <a:rPr sz="1500" b="0">
                 <a:solidFill>
@@ -6790,7 +6781,7 @@
         </p:nvSpPr>
         <p:spPr>
           <a:xfrm>
-            <a:off x="8321040" y="3419856"/>
+            <a:off x="8321040" y="3474720"/>
             <a:ext cx="3657600" cy="411480"/>
           </a:xfrm>
           <a:prstGeom prst="rect">
@@ -6804,6 +6795,7 @@
           </a:bodyPr>
           <a:lstStyle/>
           <a:p>
+            <a:pPr algn="l"/>
             <a:r>
               <a:rPr sz="1500" b="0">
                 <a:solidFill>
@@ -6823,7 +6815,7 @@
         </p:nvSpPr>
         <p:spPr>
           <a:xfrm>
-            <a:off x="8321040" y="3858768"/>
+            <a:off x="8321040" y="3931920"/>
             <a:ext cx="3657600" cy="411480"/>
           </a:xfrm>
           <a:prstGeom prst="rect">
@@ -6837,6 +6829,7 @@
           </a:bodyPr>
           <a:lstStyle/>
           <a:p>
+            <a:pPr algn="l"/>
             <a:r>
               <a:rPr sz="1500" b="0">
                 <a:solidFill>
@@ -6856,7 +6849,7 @@
         </p:nvSpPr>
         <p:spPr>
           <a:xfrm>
-            <a:off x="8321040" y="4297679"/>
+            <a:off x="8321040" y="4389120"/>
             <a:ext cx="3657600" cy="411480"/>
           </a:xfrm>
           <a:prstGeom prst="rect">
@@ -6870,6 +6863,7 @@
           </a:bodyPr>
           <a:lstStyle/>
           <a:p>
+            <a:pPr algn="l"/>
             <a:r>
               <a:rPr sz="1500" b="0">
                 <a:solidFill>
@@ -6889,7 +6883,7 @@
         </p:nvSpPr>
         <p:spPr>
           <a:xfrm>
-            <a:off x="8321040" y="4736592"/>
+            <a:off x="8321040" y="4846320"/>
             <a:ext cx="3657600" cy="411480"/>
           </a:xfrm>
           <a:prstGeom prst="rect">
@@ -6903,46 +6897,14 @@
           </a:bodyPr>
           <a:lstStyle/>
           <a:p>
+            <a:pPr algn="l"/>
             <a:r>
               <a:rPr sz="1500" b="0">
                 <a:solidFill>
                   <a:srgbClr val="000000"/>
                 </a:solidFill>
               </a:rPr>
-              <a:t>• TwoLeadECG: tied</a:t>
-            </a:r>
-          </a:p>
-        </p:txBody>
-      </p:sp>
-      <p:sp>
-        <p:nvSpPr>
-          <p:cNvPr id="15" name="TextBox 14"/>
-          <p:cNvSpPr txBox="1"/>
-          <p:nvPr/>
-        </p:nvSpPr>
-        <p:spPr>
-          <a:xfrm>
-            <a:off x="8321040" y="5175504"/>
-            <a:ext cx="3657600" cy="411480"/>
-          </a:xfrm>
-          <a:prstGeom prst="rect">
-            <a:avLst/>
-          </a:prstGeom>
-          <a:noFill/>
-        </p:spPr>
-        <p:txBody>
-          <a:bodyPr wrap="square">
-            <a:spAutoFit/>
-          </a:bodyPr>
-          <a:lstStyle/>
-          <a:p>
-            <a:r>
-              <a:rPr sz="1500" b="0">
-                <a:solidFill>
-                  <a:srgbClr val="000000"/>
-                </a:solidFill>
-              </a:rPr>
-              <a:t>• (only 23 training samples)</a:t>
+              <a:t>• TwoLeadECG: tied (23 train samples)</a:t>
             </a:r>
           </a:p>
         </p:txBody>
@@ -7169,6 +7131,7 @@
           </a:bodyPr>
           <a:lstStyle/>
           <a:p>
+            <a:pPr algn="l"/>
             <a:r>
               <a:rPr sz="1700" b="1">
                 <a:solidFill>
@@ -7202,6 +7165,7 @@
           </a:bodyPr>
           <a:lstStyle/>
           <a:p>
+            <a:pPr algn="l"/>
             <a:r>
               <a:rPr sz="1500" b="0">
                 <a:solidFill>
@@ -7221,7 +7185,7 @@
         </p:nvSpPr>
         <p:spPr>
           <a:xfrm>
-            <a:off x="7406640" y="2496312"/>
+            <a:off x="7406640" y="2505456"/>
             <a:ext cx="4572000" cy="365760"/>
           </a:xfrm>
           <a:prstGeom prst="rect">
@@ -7235,6 +7199,7 @@
           </a:bodyPr>
           <a:lstStyle/>
           <a:p>
+            <a:pPr algn="l"/>
             <a:r>
               <a:rPr sz="1500" b="0">
                 <a:solidFill>
@@ -7254,7 +7219,7 @@
         </p:nvSpPr>
         <p:spPr>
           <a:xfrm>
-            <a:off x="7406640" y="2889503"/>
+            <a:off x="7406640" y="2907791"/>
             <a:ext cx="4572000" cy="365760"/>
           </a:xfrm>
           <a:prstGeom prst="rect">
@@ -7268,13 +7233,14 @@
           </a:bodyPr>
           <a:lstStyle/>
           <a:p>
+            <a:pPr algn="l"/>
             <a:r>
               <a:rPr sz="1500" b="0">
                 <a:solidFill>
                   <a:srgbClr val="00853E"/>
                 </a:solidFill>
               </a:rPr>
-              <a:t>→ capture temporal dependence</a:t>
+              <a:t>→ temporal dependence &amp; roughness</a:t>
             </a:r>
           </a:p>
         </p:txBody>
@@ -7287,7 +7253,7 @@
         </p:nvSpPr>
         <p:spPr>
           <a:xfrm>
-            <a:off x="7406640" y="3282696"/>
+            <a:off x="7406640" y="3310128"/>
             <a:ext cx="4572000" cy="365760"/>
           </a:xfrm>
           <a:prstGeom prst="rect">
@@ -7301,13 +7267,14 @@
           </a:bodyPr>
           <a:lstStyle/>
           <a:p>
+            <a:pPr algn="l"/>
             <a:r>
               <a:rPr sz="1500" b="0">
                 <a:solidFill>
                   <a:srgbClr val="000000"/>
                 </a:solidFill>
               </a:rPr>
-              <a:t>and signal roughness</a:t>
+              <a:t/>
             </a:r>
           </a:p>
         </p:txBody>
@@ -7320,7 +7287,7 @@
         </p:nvSpPr>
         <p:spPr>
           <a:xfrm>
-            <a:off x="7406640" y="3675887"/>
+            <a:off x="7406640" y="3712463"/>
             <a:ext cx="4572000" cy="365760"/>
           </a:xfrm>
           <a:prstGeom prst="rect">
@@ -7334,13 +7301,14 @@
           </a:bodyPr>
           <a:lstStyle/>
           <a:p>
+            <a:pPr algn="l"/>
             <a:r>
               <a:rPr sz="1500" b="0">
                 <a:solidFill>
                   <a:srgbClr val="000000"/>
                 </a:solidFill>
               </a:rPr>
-              <a:t/>
+              <a:t>Pruned: hist_entropy, peak_freq</a:t>
             </a:r>
           </a:p>
         </p:txBody>
@@ -7353,7 +7321,7 @@
         </p:nvSpPr>
         <p:spPr>
           <a:xfrm>
-            <a:off x="7406640" y="4069079"/>
+            <a:off x="7406640" y="4114800"/>
             <a:ext cx="4572000" cy="365760"/>
           </a:xfrm>
           <a:prstGeom prst="rect">
@@ -7367,13 +7335,14 @@
           </a:bodyPr>
           <a:lstStyle/>
           <a:p>
+            <a:pPr algn="l"/>
             <a:r>
               <a:rPr sz="1500" b="0">
                 <a:solidFill>
-                  <a:srgbClr val="000000"/>
-                </a:solidFill>
-              </a:rPr>
-              <a:t>Pruned: hist_entropy, peak_freq</a:t>
+                  <a:srgbClr val="00853E"/>
+                </a:solidFill>
+              </a:rPr>
+              <a:t>→ removed without accuracy loss</a:t>
             </a:r>
           </a:p>
         </p:txBody>
@@ -7386,7 +7355,7 @@
         </p:nvSpPr>
         <p:spPr>
           <a:xfrm>
-            <a:off x="7406640" y="4462272"/>
+            <a:off x="7406640" y="4517136"/>
             <a:ext cx="4572000" cy="365760"/>
           </a:xfrm>
           <a:prstGeom prst="rect">
@@ -7400,13 +7369,14 @@
           </a:bodyPr>
           <a:lstStyle/>
           <a:p>
+            <a:pPr algn="l"/>
             <a:r>
               <a:rPr sz="1500" b="0">
                 <a:solidFill>
-                  <a:srgbClr val="00853E"/>
-                </a:solidFill>
-              </a:rPr>
-              <a:t>→ removed without accuracy loss</a:t>
+                  <a:srgbClr val="000000"/>
+                </a:solidFill>
+              </a:rPr>
+              <a:t/>
             </a:r>
           </a:p>
         </p:txBody>
@@ -7419,7 +7389,7 @@
         </p:nvSpPr>
         <p:spPr>
           <a:xfrm>
-            <a:off x="7406640" y="4855464"/>
+            <a:off x="7406640" y="4919472"/>
             <a:ext cx="4572000" cy="365760"/>
           </a:xfrm>
           <a:prstGeom prst="rect">
@@ -7433,13 +7403,14 @@
           </a:bodyPr>
           <a:lstStyle/>
           <a:p>
+            <a:pPr algn="l"/>
             <a:r>
               <a:rPr sz="1500" b="0">
                 <a:solidFill>
                   <a:srgbClr val="000000"/>
                 </a:solidFill>
               </a:rPr>
-              <a:t/>
+              <a:t>22 → 13 features (40% reduction)</a:t>
             </a:r>
           </a:p>
         </p:txBody>
@@ -7452,7 +7423,7 @@
         </p:nvSpPr>
         <p:spPr>
           <a:xfrm>
-            <a:off x="7406640" y="5248656"/>
+            <a:off x="7406640" y="5321808"/>
             <a:ext cx="4572000" cy="365760"/>
           </a:xfrm>
           <a:prstGeom prst="rect">
@@ -7466,13 +7437,14 @@
           </a:bodyPr>
           <a:lstStyle/>
           <a:p>
+            <a:pPr algn="l"/>
             <a:r>
               <a:rPr sz="1500" b="0">
                 <a:solidFill>
                   <a:srgbClr val="000000"/>
                 </a:solidFill>
               </a:rPr>
-              <a:t>22 → 13 features (40% reduction)</a:t>
+              <a:t>XAI as a design tool,</a:t>
             </a:r>
           </a:p>
         </p:txBody>
@@ -7485,7 +7457,7 @@
         </p:nvSpPr>
         <p:spPr>
           <a:xfrm>
-            <a:off x="7406640" y="5641848"/>
+            <a:off x="7406640" y="5724144"/>
             <a:ext cx="4572000" cy="365760"/>
           </a:xfrm>
           <a:prstGeom prst="rect">
@@ -7499,39 +7471,7 @@
           </a:bodyPr>
           <a:lstStyle/>
           <a:p>
-            <a:r>
-              <a:rPr sz="1500" b="0">
-                <a:solidFill>
-                  <a:srgbClr val="000000"/>
-                </a:solidFill>
-              </a:rPr>
-              <a:t>XAI used as a design tool,</a:t>
-            </a:r>
-          </a:p>
-        </p:txBody>
-      </p:sp>
-      <p:sp>
-        <p:nvSpPr>
-          <p:cNvPr id="18" name="TextBox 17"/>
-          <p:cNvSpPr txBox="1"/>
-          <p:nvPr/>
-        </p:nvSpPr>
-        <p:spPr>
-          <a:xfrm>
-            <a:off x="7406640" y="6035040"/>
-            <a:ext cx="4572000" cy="365760"/>
-          </a:xfrm>
-          <a:prstGeom prst="rect">
-            <a:avLst/>
-          </a:prstGeom>
-          <a:noFill/>
-        </p:spPr>
-        <p:txBody>
-          <a:bodyPr wrap="square">
-            <a:spAutoFit/>
-          </a:bodyPr>
-          <a:lstStyle/>
-          <a:p>
+            <a:pPr algn="l"/>
             <a:r>
               <a:rPr sz="1500" b="0">
                 <a:solidFill>

</xml_diff>

<commit_message>
Fix: clean up Thank You slide layout
</commit_message>
<xml_diff>
--- a/slides/Group18_UNT_Presentation.pptx
+++ b/slides/Group18_UNT_Presentation.pptx
@@ -4165,42 +4165,16 @@
             <p:ph idx="1"/>
           </p:nvPr>
         </p:nvSpPr>
-        <p:spPr/>
+        <p:spPr>
+          <a:xfrm>
+            <a:off x="18288000" y="18288000"/>
+            <a:ext cx="91440" cy="91440"/>
+          </a:xfrm>
+        </p:spPr>
         <p:txBody>
           <a:bodyPr/>
           <a:lstStyle/>
-          <a:p>
-            <a:r>
-              <a:rPr lang="en-US" dirty="0"/>
-              <a:t>Dataset Exploration: Briefly show the raw dataset and preprocessing steps.</a:t>
-            </a:r>
-          </a:p>
-          <a:p>
-            <a:r>
-              <a:rPr lang="en-US" dirty="0"/>
-              <a:t>Feature Engineering: Demonstrate the implementation of one or two feature engineering techniques. Include live code execution or pre-recorded segments for computationally intensive steps.</a:t>
-            </a:r>
-          </a:p>
-          <a:p>
-            <a:r>
-              <a:rPr lang="en-US" dirty="0"/>
-              <a:t>Model Evaluation: Run the models and display metrics or visualizations comparing results before and after feature engineering.</a:t>
-            </a:r>
-          </a:p>
-          <a:p>
-            <a:r>
-              <a:rPr lang="en-US" dirty="0"/>
-              <a:t>Automated Feature Engineering: If applicable, demonstrate the use of </a:t>
-            </a:r>
-            <a:r>
-              <a:rPr lang="en-US" dirty="0" err="1"/>
-              <a:t>AutoFE</a:t>
-            </a:r>
-            <a:r>
-              <a:rPr lang="en-US" dirty="0"/>
-              <a:t> tools and compare results.</a:t>
-            </a:r>
-          </a:p>
+          <a:p/>
         </p:txBody>
       </p:sp>
       <p:sp>
@@ -4240,8 +4214,8 @@
         </p:nvSpPr>
         <p:spPr>
           <a:xfrm>
-            <a:off x="1371600" y="2743200"/>
-            <a:ext cx="9445752" cy="502920"/>
+            <a:off x="1371600" y="2560320"/>
+            <a:ext cx="9445752" cy="548640"/>
           </a:xfrm>
           <a:prstGeom prst="rect">
             <a:avLst/>
@@ -4256,7 +4230,7 @@
           <a:p>
             <a:pPr algn="ctr"/>
             <a:r>
-              <a:rPr sz="2400" b="0">
+              <a:rPr sz="2600" b="0">
                 <a:solidFill>
                   <a:srgbClr val="444444"/>
                 </a:solidFill>
@@ -4268,14 +4242,57 @@
       </p:sp>
       <p:sp>
         <p:nvSpPr>
-          <p:cNvPr id="6" name="TextBox 5"/>
+          <p:cNvPr id="6" name="Rectangle 5"/>
+          <p:cNvSpPr/>
+          <p:nvPr/>
+        </p:nvSpPr>
+        <p:spPr>
+          <a:xfrm>
+            <a:off x="3200400" y="3246120"/>
+            <a:ext cx="5788152" cy="36576"/>
+          </a:xfrm>
+          <a:prstGeom prst="rect">
+            <a:avLst/>
+          </a:prstGeom>
+          <a:solidFill>
+            <a:srgbClr val="00853E"/>
+          </a:solidFill>
+          <a:ln>
+            <a:noFill/>
+          </a:ln>
+        </p:spPr>
+        <p:style>
+          <a:lnRef idx="1">
+            <a:schemeClr val="accent1"/>
+          </a:lnRef>
+          <a:fillRef idx="3">
+            <a:schemeClr val="accent1"/>
+          </a:fillRef>
+          <a:effectRef idx="2">
+            <a:schemeClr val="accent1"/>
+          </a:effectRef>
+          <a:fontRef idx="minor">
+            <a:schemeClr val="lt1"/>
+          </a:fontRef>
+        </p:style>
+        <p:txBody>
+          <a:bodyPr rtlCol="0" anchor="ctr"/>
+          <a:lstStyle/>
+          <a:p>
+            <a:pPr algn="ctr"/>
+          </a:p>
+        </p:txBody>
+      </p:sp>
+      <p:sp>
+        <p:nvSpPr>
+          <p:cNvPr id="7" name="TextBox 6"/>
           <p:cNvSpPr txBox="1"/>
           <p:nvPr/>
         </p:nvSpPr>
         <p:spPr>
           <a:xfrm>
-            <a:off x="1371600" y="3383280"/>
-            <a:ext cx="9445752" cy="411480"/>
+            <a:off x="1371600" y="3429000"/>
+            <a:ext cx="9445752" cy="438912"/>
           </a:xfrm>
           <a:prstGeom prst="rect">
             <a:avLst/>
@@ -4290,7 +4307,7 @@
           <a:p>
             <a:pPr algn="ctr"/>
             <a:r>
-              <a:rPr sz="1700" b="0">
+              <a:rPr sz="1800" b="0">
                 <a:solidFill>
                   <a:srgbClr val="000000"/>
                 </a:solidFill>
@@ -4302,14 +4319,14 @@
       </p:sp>
       <p:sp>
         <p:nvSpPr>
-          <p:cNvPr id="7" name="TextBox 6"/>
+          <p:cNvPr id="8" name="TextBox 7"/>
           <p:cNvSpPr txBox="1"/>
           <p:nvPr/>
         </p:nvSpPr>
         <p:spPr>
           <a:xfrm>
-            <a:off x="1371600" y="3840480"/>
-            <a:ext cx="9445752" cy="411480"/>
+            <a:off x="1371600" y="3913632"/>
+            <a:ext cx="9445752" cy="438912"/>
           </a:xfrm>
           <a:prstGeom prst="rect">
             <a:avLst/>
@@ -4324,7 +4341,7 @@
           <a:p>
             <a:pPr algn="ctr"/>
             <a:r>
-              <a:rPr sz="1700" b="0">
+              <a:rPr sz="1800" b="0">
                 <a:solidFill>
                   <a:srgbClr val="000000"/>
                 </a:solidFill>
@@ -4336,13 +4353,13 @@
       </p:sp>
       <p:sp>
         <p:nvSpPr>
-          <p:cNvPr id="8" name="TextBox 7"/>
+          <p:cNvPr id="9" name="TextBox 8"/>
           <p:cNvSpPr txBox="1"/>
           <p:nvPr/>
         </p:nvSpPr>
         <p:spPr>
           <a:xfrm>
-            <a:off x="1371600" y="4434840"/>
+            <a:off x="1371600" y="4526280"/>
             <a:ext cx="9445752" cy="411480"/>
           </a:xfrm>
           <a:prstGeom prst="rect">
@@ -4363,20 +4380,20 @@
                   <a:srgbClr val="00853E"/>
                 </a:solidFill>
               </a:rPr>
-              <a:t>GitHub: github.com/Ash-projects-personal/CSCE5222-Group18-FeatureEngineering</a:t>
-            </a:r>
-          </a:p>
-        </p:txBody>
-      </p:sp>
-      <p:sp>
-        <p:nvSpPr>
-          <p:cNvPr id="9" name="TextBox 8"/>
+              <a:t>github.com/Ash-projects-personal/CSCE5222-Group18-FeatureEngineering</a:t>
+            </a:r>
+          </a:p>
+        </p:txBody>
+      </p:sp>
+      <p:sp>
+        <p:nvSpPr>
+          <p:cNvPr id="10" name="TextBox 9"/>
           <p:cNvSpPr txBox="1"/>
           <p:nvPr/>
         </p:nvSpPr>
         <p:spPr>
           <a:xfrm>
-            <a:off x="1371600" y="4937760"/>
+            <a:off x="1371600" y="5029200"/>
             <a:ext cx="9445752" cy="365760"/>
           </a:xfrm>
           <a:prstGeom prst="rect">

</xml_diff>

<commit_message>
Final deliverables: 10-page report + updated slides matching actual notebook results
</commit_message>
<xml_diff>
--- a/slides/Group18_UNT_Presentation.pptx
+++ b/slides/Group18_UNT_Presentation.pptx
@@ -4165,16 +4165,42 @@
             <p:ph idx="1"/>
           </p:nvPr>
         </p:nvSpPr>
-        <p:spPr>
-          <a:xfrm>
-            <a:off x="18288000" y="18288000"/>
-            <a:ext cx="91440" cy="91440"/>
-          </a:xfrm>
-        </p:spPr>
+        <p:spPr/>
         <p:txBody>
           <a:bodyPr/>
           <a:lstStyle/>
-          <a:p/>
+          <a:p>
+            <a:r>
+              <a:rPr lang="en-US" dirty="0"/>
+              <a:t>Dataset Exploration: Briefly show the raw dataset and preprocessing steps.</a:t>
+            </a:r>
+          </a:p>
+          <a:p>
+            <a:r>
+              <a:rPr lang="en-US" dirty="0"/>
+              <a:t>Feature Engineering: Demonstrate the implementation of one or two feature engineering techniques. Include live code execution or pre-recorded segments for computationally intensive steps.</a:t>
+            </a:r>
+          </a:p>
+          <a:p>
+            <a:r>
+              <a:rPr lang="en-US" dirty="0"/>
+              <a:t>Model Evaluation: Run the models and display metrics or visualizations comparing results before and after feature engineering.</a:t>
+            </a:r>
+          </a:p>
+          <a:p>
+            <a:r>
+              <a:rPr lang="en-US" dirty="0"/>
+              <a:t>Automated Feature Engineering: If applicable, demonstrate the use of </a:t>
+            </a:r>
+            <a:r>
+              <a:rPr lang="en-US" dirty="0" err="1"/>
+              <a:t>AutoFE</a:t>
+            </a:r>
+            <a:r>
+              <a:rPr lang="en-US" dirty="0"/>
+              <a:t> tools and compare results.</a:t>
+            </a:r>
+          </a:p>
         </p:txBody>
       </p:sp>
       <p:sp>
@@ -4214,8 +4240,8 @@
         </p:nvSpPr>
         <p:spPr>
           <a:xfrm>
-            <a:off x="1371600" y="2560320"/>
-            <a:ext cx="9445752" cy="548640"/>
+            <a:off x="1371600" y="2743200"/>
+            <a:ext cx="9445752" cy="502920"/>
           </a:xfrm>
           <a:prstGeom prst="rect">
             <a:avLst/>
@@ -4230,7 +4256,7 @@
           <a:p>
             <a:pPr algn="ctr"/>
             <a:r>
-              <a:rPr sz="2600" b="0">
+              <a:rPr sz="2400" b="0">
                 <a:solidFill>
                   <a:srgbClr val="444444"/>
                 </a:solidFill>
@@ -4242,44 +4268,35 @@
       </p:sp>
       <p:sp>
         <p:nvSpPr>
-          <p:cNvPr id="6" name="Rectangle 5"/>
-          <p:cNvSpPr/>
+          <p:cNvPr id="6" name="TextBox 5"/>
+          <p:cNvSpPr txBox="1"/>
           <p:nvPr/>
         </p:nvSpPr>
         <p:spPr>
           <a:xfrm>
-            <a:off x="3200400" y="3246120"/>
-            <a:ext cx="5788152" cy="36576"/>
-          </a:xfrm>
-          <a:prstGeom prst="rect">
-            <a:avLst/>
-          </a:prstGeom>
-          <a:solidFill>
-            <a:srgbClr val="00853E"/>
-          </a:solidFill>
-          <a:ln>
-            <a:noFill/>
-          </a:ln>
-        </p:spPr>
-        <p:style>
-          <a:lnRef idx="1">
-            <a:schemeClr val="accent1"/>
-          </a:lnRef>
-          <a:fillRef idx="3">
-            <a:schemeClr val="accent1"/>
-          </a:fillRef>
-          <a:effectRef idx="2">
-            <a:schemeClr val="accent1"/>
-          </a:effectRef>
-          <a:fontRef idx="minor">
-            <a:schemeClr val="lt1"/>
-          </a:fontRef>
-        </p:style>
-        <p:txBody>
-          <a:bodyPr rtlCol="0" anchor="ctr"/>
+            <a:off x="1371600" y="3383280"/>
+            <a:ext cx="9445752" cy="411480"/>
+          </a:xfrm>
+          <a:prstGeom prst="rect">
+            <a:avLst/>
+          </a:prstGeom>
+          <a:noFill/>
+        </p:spPr>
+        <p:txBody>
+          <a:bodyPr wrap="square">
+            <a:spAutoFit/>
+          </a:bodyPr>
           <a:lstStyle/>
           <a:p>
             <a:pPr algn="ctr"/>
+            <a:r>
+              <a:rPr sz="1700" b="0">
+                <a:solidFill>
+                  <a:srgbClr val="000000"/>
+                </a:solidFill>
+              </a:rPr>
+              <a:t>Ashish Rathnakar Shetty  ·  ashishrathnakarshetty@unt.edu</a:t>
+            </a:r>
           </a:p>
         </p:txBody>
       </p:sp>
@@ -4291,8 +4308,8 @@
         </p:nvSpPr>
         <p:spPr>
           <a:xfrm>
-            <a:off x="1371600" y="3429000"/>
-            <a:ext cx="9445752" cy="438912"/>
+            <a:off x="1371600" y="3840480"/>
+            <a:ext cx="9445752" cy="411480"/>
           </a:xfrm>
           <a:prstGeom prst="rect">
             <a:avLst/>
@@ -4307,12 +4324,12 @@
           <a:p>
             <a:pPr algn="ctr"/>
             <a:r>
-              <a:rPr sz="1800" b="0">
-                <a:solidFill>
-                  <a:srgbClr val="000000"/>
-                </a:solidFill>
-              </a:rPr>
-              <a:t>Ashish Rathnakar Shetty  ·  ashishrathnakarshetty@unt.edu</a:t>
+              <a:rPr sz="1700" b="0">
+                <a:solidFill>
+                  <a:srgbClr val="000000"/>
+                </a:solidFill>
+              </a:rPr>
+              <a:t>Kushal Sai Venigalla  ·  KushalSaiVenigalla@unt.edu</a:t>
             </a:r>
           </a:p>
         </p:txBody>
@@ -4325,8 +4342,8 @@
         </p:nvSpPr>
         <p:spPr>
           <a:xfrm>
-            <a:off x="1371600" y="3913632"/>
-            <a:ext cx="9445752" cy="438912"/>
+            <a:off x="1371600" y="4434840"/>
+            <a:ext cx="9445752" cy="411480"/>
           </a:xfrm>
           <a:prstGeom prst="rect">
             <a:avLst/>
@@ -4341,12 +4358,12 @@
           <a:p>
             <a:pPr algn="ctr"/>
             <a:r>
-              <a:rPr sz="1800" b="0">
-                <a:solidFill>
-                  <a:srgbClr val="000000"/>
-                </a:solidFill>
-              </a:rPr>
-              <a:t>Kushal Sai Venigalla  ·  KushalSaiVenigalla@unt.edu</a:t>
+              <a:rPr sz="1500" b="0">
+                <a:solidFill>
+                  <a:srgbClr val="00853E"/>
+                </a:solidFill>
+              </a:rPr>
+              <a:t>GitHub: github.com/Ash-projects-personal/CSCE5222-Group18-FeatureEngineering</a:t>
             </a:r>
           </a:p>
         </p:txBody>
@@ -4359,41 +4376,7 @@
         </p:nvSpPr>
         <p:spPr>
           <a:xfrm>
-            <a:off x="1371600" y="4526280"/>
-            <a:ext cx="9445752" cy="411480"/>
-          </a:xfrm>
-          <a:prstGeom prst="rect">
-            <a:avLst/>
-          </a:prstGeom>
-          <a:noFill/>
-        </p:spPr>
-        <p:txBody>
-          <a:bodyPr wrap="square">
-            <a:spAutoFit/>
-          </a:bodyPr>
-          <a:lstStyle/>
-          <a:p>
-            <a:pPr algn="ctr"/>
-            <a:r>
-              <a:rPr sz="1500" b="0">
-                <a:solidFill>
-                  <a:srgbClr val="00853E"/>
-                </a:solidFill>
-              </a:rPr>
-              <a:t>github.com/Ash-projects-personal/CSCE5222-Group18-FeatureEngineering</a:t>
-            </a:r>
-          </a:p>
-        </p:txBody>
-      </p:sp>
-      <p:sp>
-        <p:nvSpPr>
-          <p:cNvPr id="10" name="TextBox 9"/>
-          <p:cNvSpPr txBox="1"/>
-          <p:nvPr/>
-        </p:nvSpPr>
-        <p:spPr>
-          <a:xfrm>
-            <a:off x="1371600" y="5029200"/>
+            <a:off x="1371600" y="4937760"/>
             <a:ext cx="9445752" cy="365760"/>
           </a:xfrm>
           <a:prstGeom prst="rect">

</xml_diff>